<commit_message>
Correct public typography highlight ordering and accents
Validate DrawingML highlight child ordering in the public PPTX inventory. Correct four fixtures and three generator cases; retain strict boundary emission gates and document their operation-count mismatch.
</commit_message>
<xml_diff>
--- a/tests/Lokad.OoxPdf.Tests/Cases/pptx-ladder-04-typography-boundary-invariance-probe.pptx
+++ b/tests/Lokad.OoxPdf.Tests/Cases/pptx-ladder-04-typography-boundary-invariance-probe.pptx
@@ -3396,10 +3396,10 @@
             </a:r>
             <a:r>
               <a:rPr sz="2800">
-                <a:latin typeface="Arial"/>
                 <a:highlight>
                   <a:srgbClr val="FFF200"/>
                 </a:highlight>
+                <a:latin typeface="Arial"/>
               </a:rPr>
               <a:t>Global </a:t>
             </a:r>
@@ -3416,16 +3416,16 @@
               <a:rPr sz="2800">
                 <a:latin typeface="Arial"/>
               </a:rPr>
-              <a:t>DÃ©pendance </a:t>
+              <a:t>Dépendance </a:t>
             </a:r>
             <a:r>
               <a:rPr sz="2800">
-                <a:latin typeface="Arial"/>
                 <a:highlight>
                   <a:srgbClr val="FFF200"/>
                 </a:highlight>
+                <a:latin typeface="Arial"/>
               </a:rPr>
-              <a:t>Ã©levÃ©e</a:t>
+              <a:t>élevée</a:t>
             </a:r>
           </a:p>
         </p:txBody>

</xml_diff>